<commit_message>
chore(saidas): regeração com os erros corrigidos
</commit_message>
<xml_diff>
--- a/analises_exploratorias/00_sintese/00_sintese.pptx
+++ b/analises_exploratorias/00_sintese/00_sintese.pptx
@@ -1582,7 +1582,7 @@
               <a:rPr lang="en-US" dirty="0"/>
               <a:t>As versões que mudam o recorte (eixo A) comparam só os setores em comum com a referência.
 Como ler: Uma barra por versão com o percentual de setores que mudam de faixa (regra do IVS-BH); petróleo: elegível; argila: não elegível.
-O que mostra: A maior mudança é a de D2_ivs_idoso: 49,8% dos setores mudam de faixa.</a:t>
+O que mostra: A maior mudança é a de D2_ivs_idoso: 49,9% dos setores mudam de faixa.</a:t>
             </a:r>
             <a:endParaRPr lang="en-US" dirty="0"/>
           </a:p>
@@ -7176,7 +7176,7 @@
                           <a:ea typeface="Cambria" pitchFamily="34" charset="-122"/>
                           <a:cs typeface="Cambria" pitchFamily="34" charset="-120"/>
                         </a:rPr>
-                        <a:t>73.878</a:t>
+                        <a:t>73.877</a:t>
                       </a:r>
                       <a:endParaRPr lang="en-US" sz="1000" dirty="0">
                         <a:latin typeface="Cambria" charset="0"/>
@@ -7742,7 +7742,7 @@
                           <a:ea typeface="Cambria" pitchFamily="34" charset="-122"/>
                           <a:cs typeface="Cambria" pitchFamily="34" charset="-120"/>
                         </a:rPr>
-                        <a:t>3,7%</a:t>
+                        <a:t>1,6%</a:t>
                       </a:r>
                       <a:endParaRPr lang="en-US" sz="1000" dirty="0">
                         <a:latin typeface="Cambria" charset="0"/>
@@ -7838,7 +7838,7 @@
                           <a:ea typeface="Cambria" pitchFamily="34" charset="-122"/>
                           <a:cs typeface="Cambria" pitchFamily="34" charset="-120"/>
                         </a:rPr>
-                        <a:t>73.407</a:t>
+                        <a:t>73.406</a:t>
                       </a:r>
                       <a:endParaRPr lang="en-US" sz="1000" dirty="0">
                         <a:latin typeface="Cambria" charset="0"/>
@@ -8073,7 +8073,7 @@
                           <a:ea typeface="Cambria" pitchFamily="34" charset="-122"/>
                           <a:cs typeface="Cambria" pitchFamily="34" charset="-120"/>
                         </a:rPr>
-                        <a:t>1,6%</a:t>
+                        <a:t>1,5%</a:t>
                       </a:r>
                       <a:endParaRPr lang="en-US" sz="1000" dirty="0">
                         <a:latin typeface="Cambria" charset="0"/>
@@ -11479,7 +11479,7 @@
                           <a:ea typeface="Cambria" pitchFamily="34" charset="-122"/>
                           <a:cs typeface="Cambria" pitchFamily="34" charset="-120"/>
                         </a:rPr>
-                        <a:t>73.877</a:t>
+                        <a:t>73.876</a:t>
                       </a:r>
                       <a:endParaRPr lang="en-US" sz="1000" dirty="0">
                         <a:latin typeface="Cambria" charset="0"/>
@@ -11810,7 +11810,7 @@
                           <a:ea typeface="Cambria" pitchFamily="34" charset="-122"/>
                           <a:cs typeface="Cambria" pitchFamily="34" charset="-120"/>
                         </a:rPr>
-                        <a:t>73.854</a:t>
+                        <a:t>73.853</a:t>
                       </a:r>
                       <a:endParaRPr lang="en-US" sz="1000" dirty="0">
                         <a:latin typeface="Cambria" charset="0"/>
@@ -12329,7 +12329,7 @@
                           <a:ea typeface="Cambria" pitchFamily="34" charset="-122"/>
                           <a:cs typeface="Cambria" pitchFamily="34" charset="-120"/>
                         </a:rPr>
-                        <a:t>0,9907</a:t>
+                        <a:t>0,9908</a:t>
                       </a:r>
                       <a:endParaRPr lang="en-US" sz="1000" dirty="0">
                         <a:latin typeface="Cambria" charset="0"/>
@@ -12376,7 +12376,7 @@
                           <a:ea typeface="Cambria" pitchFamily="34" charset="-122"/>
                           <a:cs typeface="Cambria" pitchFamily="34" charset="-120"/>
                         </a:rPr>
-                        <a:t>13,0%</a:t>
+                        <a:t>8,9%</a:t>
                       </a:r>
                       <a:endParaRPr lang="en-US" sz="1000" dirty="0">
                         <a:latin typeface="Cambria" charset="0"/>
@@ -13193,7 +13193,7 @@
                           <a:ea typeface="Cambria" pitchFamily="34" charset="-122"/>
                           <a:cs typeface="Cambria" pitchFamily="34" charset="-120"/>
                         </a:rPr>
-                        <a:t>73.878</a:t>
+                        <a:t>73.877</a:t>
                       </a:r>
                       <a:endParaRPr lang="en-US" sz="1000" dirty="0">
                         <a:latin typeface="Cambria" charset="0"/>
@@ -13524,7 +13524,7 @@
                           <a:ea typeface="Cambria" pitchFamily="34" charset="-122"/>
                           <a:cs typeface="Cambria" pitchFamily="34" charset="-120"/>
                         </a:rPr>
-                        <a:t>73.878</a:t>
+                        <a:t>73.877</a:t>
                       </a:r>
                       <a:endParaRPr lang="en-US" sz="1000" dirty="0">
                         <a:latin typeface="Cambria" charset="0"/>
@@ -13855,7 +13855,7 @@
                           <a:ea typeface="Cambria" pitchFamily="34" charset="-122"/>
                           <a:cs typeface="Cambria" pitchFamily="34" charset="-120"/>
                         </a:rPr>
-                        <a:t>73.878</a:t>
+                        <a:t>73.877</a:t>
                       </a:r>
                       <a:endParaRPr lang="en-US" sz="1000" dirty="0">
                         <a:latin typeface="Cambria" charset="0"/>
@@ -14186,7 +14186,7 @@
                           <a:ea typeface="Cambria" pitchFamily="34" charset="-122"/>
                           <a:cs typeface="Cambria" pitchFamily="34" charset="-120"/>
                         </a:rPr>
-                        <a:t>73.879</a:t>
+                        <a:t>73.878</a:t>
                       </a:r>
                       <a:endParaRPr lang="en-US" sz="1000" dirty="0">
                         <a:latin typeface="Cambria" charset="0"/>
@@ -14517,7 +14517,7 @@
                           <a:ea typeface="Cambria" pitchFamily="34" charset="-122"/>
                           <a:cs typeface="Cambria" pitchFamily="34" charset="-120"/>
                         </a:rPr>
-                        <a:t>73.794</a:t>
+                        <a:t>73.793</a:t>
                       </a:r>
                       <a:endParaRPr lang="en-US" sz="1000" dirty="0">
                         <a:latin typeface="Cambria" charset="0"/>
@@ -14848,7 +14848,7 @@
                           <a:ea typeface="Cambria" pitchFamily="34" charset="-122"/>
                           <a:cs typeface="Cambria" pitchFamily="34" charset="-120"/>
                         </a:rPr>
-                        <a:t>73.878</a:t>
+                        <a:t>73.877</a:t>
                       </a:r>
                       <a:endParaRPr lang="en-US" sz="1000" dirty="0">
                         <a:latin typeface="Cambria" charset="0"/>
@@ -15179,7 +15179,7 @@
                           <a:ea typeface="Cambria" pitchFamily="34" charset="-122"/>
                           <a:cs typeface="Cambria" pitchFamily="34" charset="-120"/>
                         </a:rPr>
-                        <a:t>73.878</a:t>
+                        <a:t>73.877</a:t>
                       </a:r>
                       <a:endParaRPr lang="en-US" sz="1000" dirty="0">
                         <a:latin typeface="Cambria" charset="0"/>
@@ -16172,7 +16172,7 @@
                           <a:ea typeface="Cambria" pitchFamily="34" charset="-122"/>
                           <a:cs typeface="Cambria" pitchFamily="34" charset="-120"/>
                         </a:rPr>
-                        <a:t>73.878</a:t>
+                        <a:t>73.877</a:t>
                       </a:r>
                       <a:endParaRPr lang="en-US" sz="1000" dirty="0">
                         <a:latin typeface="Cambria" charset="0"/>
@@ -16503,7 +16503,7 @@
                           <a:ea typeface="Cambria" pitchFamily="34" charset="-122"/>
                           <a:cs typeface="Cambria" pitchFamily="34" charset="-120"/>
                         </a:rPr>
-                        <a:t>73.878</a:t>
+                        <a:t>73.877</a:t>
                       </a:r>
                       <a:endParaRPr lang="en-US" sz="1000" dirty="0">
                         <a:latin typeface="Cambria" charset="0"/>
@@ -16834,7 +16834,7 @@
                           <a:ea typeface="Cambria" pitchFamily="34" charset="-122"/>
                           <a:cs typeface="Cambria" pitchFamily="34" charset="-120"/>
                         </a:rPr>
-                        <a:t>73.878</a:t>
+                        <a:t>73.877</a:t>
                       </a:r>
                       <a:endParaRPr lang="en-US" sz="1000" dirty="0">
                         <a:latin typeface="Cambria" charset="0"/>
@@ -17165,7 +17165,7 @@
                           <a:ea typeface="Cambria" pitchFamily="34" charset="-122"/>
                           <a:cs typeface="Cambria" pitchFamily="34" charset="-120"/>
                         </a:rPr>
-                        <a:t>73.250</a:t>
+                        <a:t>73.249</a:t>
                       </a:r>
                       <a:endParaRPr lang="en-US" sz="1000" dirty="0">
                         <a:latin typeface="Cambria" charset="0"/>
@@ -17400,7 +17400,7 @@
                           <a:ea typeface="Cambria" pitchFamily="34" charset="-122"/>
                           <a:cs typeface="Cambria" pitchFamily="34" charset="-120"/>
                         </a:rPr>
-                        <a:t>49,8%</a:t>
+                        <a:t>49,9%</a:t>
                       </a:r>
                       <a:endParaRPr lang="en-US" sz="1000" dirty="0">
                         <a:latin typeface="Cambria" charset="0"/>
@@ -18062,7 +18062,7 @@
                           <a:ea typeface="Cambria" pitchFamily="34" charset="-122"/>
                           <a:cs typeface="Cambria" pitchFamily="34" charset="-120"/>
                         </a:rPr>
-                        <a:t>25,1%</a:t>
+                        <a:t>24,8%</a:t>
                       </a:r>
                       <a:endParaRPr lang="en-US" sz="1000" dirty="0">
                         <a:latin typeface="Cambria" charset="0"/>
@@ -18158,7 +18158,7 @@
                           <a:ea typeface="Cambria" pitchFamily="34" charset="-122"/>
                           <a:cs typeface="Cambria" pitchFamily="34" charset="-120"/>
                         </a:rPr>
-                        <a:t>73.878</a:t>
+                        <a:t>73.877</a:t>
                       </a:r>
                       <a:endParaRPr lang="en-US" sz="1000" dirty="0">
                         <a:latin typeface="Cambria" charset="0"/>
@@ -20196,7 +20196,7 @@
                           <a:ea typeface="Cambria" pitchFamily="34" charset="-122"/>
                           <a:cs typeface="Cambria" pitchFamily="34" charset="-120"/>
                         </a:rPr>
-                        <a:t>49,8%</a:t>
+                        <a:t>49,9%</a:t>
                       </a:r>
                       <a:endParaRPr lang="en-US" sz="1000" dirty="0">
                         <a:latin typeface="Cambria" charset="0"/>
@@ -20764,7 +20764,7 @@
                           <a:ea typeface="Cambria" pitchFamily="34" charset="-122"/>
                           <a:cs typeface="Cambria" pitchFamily="34" charset="-120"/>
                         </a:rPr>
-                        <a:t>49,8%</a:t>
+                        <a:t>49,9%</a:t>
                       </a:r>
                       <a:endParaRPr lang="en-US" sz="1000" dirty="0">
                         <a:latin typeface="Cambria" charset="0"/>
@@ -21608,7 +21608,7 @@
                 <a:ea typeface="Cambria" pitchFamily="34" charset="-122"/>
                 <a:cs typeface="Cambria" pitchFamily="34" charset="-120"/>
               </a:rPr>
-              <a:t>A maior mudança é a de D2_ivs_idoso: 49,8% dos setores mudam de faixa.</a:t>
+              <a:t>A maior mudança é a de D2_ivs_idoso: 49,9% dos setores mudam de faixa.</a:t>
             </a:r>
             <a:endParaRPr lang="en-US" sz="1250" dirty="0"/>
           </a:p>

</xml_diff>